<commit_message>
feat(growth): 以 Growth 全量覆盖 Growthmatrix 并统一项目名称 [T-2026-0927-0007]
</commit_message>
<xml_diff>
--- a/docs/capability-tour.pptx
+++ b/docs/capability-tour.pptx
@@ -3133,7 +3133,7 @@
                 </a:solidFill>
                 <a:latin typeface="PingFang SC"/>
               </a:rPr>
-              <a:t>workloom-ai-acquisition · 能力导览</a:t>
+              <a:t>Growthmatrix·骇客帝国 · 能力导览</a:t>
             </a:r>
           </a:p>
           <a:p>
@@ -3145,7 +3145,7 @@
                 </a:solidFill>
                 <a:latin typeface="PingFang SC"/>
               </a:rPr>
-              <a:t>WorkLoom 获客系统 · 短视频社媒营销 × GEO × 获客五环 × 行业运营（首垂直：酒店）</a:t>
+              <a:t>Growthmatrix·骇客帝国 · 短视频社媒营销 × GEO × 获客五环 × 行业运营（首垂直：酒店）</a:t>
             </a:r>
           </a:p>
           <a:p>

</xml_diff>

<commit_message>
feat(growth): 以 Growth 全量重置 Growthmatrix 并隔离项目身份 [T-2026-0927-0007]
以 Growth@7d349993c30051d87efac379b75e2173304a66d7 完整替换目标文件树，统一 Growthmatrix·骇客帝国 项目名称与对应派生身份。用户已明确授权完整覆盖及云端合并。任务 #91。
</commit_message>
<xml_diff>
--- a/docs/capability-tour.pptx
+++ b/docs/capability-tour.pptx
@@ -3133,7 +3133,7 @@
                 </a:solidFill>
                 <a:latin typeface="PingFang SC"/>
               </a:rPr>
-              <a:t>workloom-ai-acquisition · 能力导览</a:t>
+              <a:t>Growthmatrix·骇客帝国 · 能力导览</a:t>
             </a:r>
           </a:p>
           <a:p>
@@ -3145,7 +3145,7 @@
                 </a:solidFill>
                 <a:latin typeface="PingFang SC"/>
               </a:rPr>
-              <a:t>WorkLoom 获客系统 · 短视频社媒营销 × GEO × 获客五环 × 行业运营（首垂直：酒店）</a:t>
+              <a:t>Growthmatrix·骇客帝国 · 短视频社媒营销 × GEO × 获客五环 × 行业运营（首垂直：酒店）</a:t>
             </a:r>
           </a:p>
           <a:p>

</xml_diff>

<commit_message>
sync(growthmatrix): 以 growth main(2b2ff15) 全量覆盖 + 全面改名 growth→growthmatrix
按产品所有者指令执行：
1. 清空 growthmatrix 工作树（保留 .git）；
2. 从 workloom-growth main `2b2ff15`（含 GR-01..GR-27 / N-01..N-16 / X-01..X-10 / Y-01 全部修复）全量复制；
3. 标识改名（6 类，含目录）：
   - workloom-growth → workloom-growthmatrix
   - WorkLoom-growth → WorkLoom-growthmatrix
   - workloom_growth → workloom_growthmatrix（含 .env.example 数据库名）
   - WorkLoom Growth → WorkLoom GrowthMatrix
   - workloom-ai-growth → workloom-ai-growthmatrix（product.manifest.json productId）
   - geo-growth → geo-growthmatrix（行业包目录 bundles/geo-growthmatrix + industry 字段 + 全仓引用）
   改名后已做大小写无关的重复名纠偏（matrixmatrix/MatrixMatrix → matrix/Matrix），全仓无旧名残留。

验证：bundle 治理门禁通过；pnpm typecheck 全绿；新库 workloom_gm 迁移 54 文件 + 种子通过；
pnpm suite 471/471 通过（含第四/五批新增的联动与安全用例）。
</commit_message>
<xml_diff>
--- a/docs/capability-tour.pptx
+++ b/docs/capability-tour.pptx
@@ -3133,7 +3133,7 @@
                 </a:solidFill>
                 <a:latin typeface="PingFang SC"/>
               </a:rPr>
-              <a:t>Growthmatrix·骇客帝国 · 能力导览</a:t>
+              <a:t>workloom-ai-acquisition · 能力导览</a:t>
             </a:r>
           </a:p>
           <a:p>
@@ -3145,7 +3145,7 @@
                 </a:solidFill>
                 <a:latin typeface="PingFang SC"/>
               </a:rPr>
-              <a:t>Growthmatrix·骇客帝国 · 短视频社媒营销 × GEO × 获客五环 × 行业运营（首垂直：酒店）</a:t>
+              <a:t>WorkLoom 获客系统 · 短视频社媒营销 × GEO × 获客五环 × 行业运营（首垂直：酒店）</a:t>
             </a:r>
           </a:p>
           <a:p>

</xml_diff>